<commit_message>
Refine portfolio identity, case stories, and responsive evidence
</commit_message>
<xml_diff>
--- a/downloads/design/kyle-hobson-design-deck.pptx
+++ b/downloads/design/kyle-hobson-design-deck.pptx
@@ -2,22 +2,22 @@
 <file path=ppt/presentation.xml><?xml version="1.0" encoding="utf-8"?>
 <p:presentation xmlns:p="http://schemas.openxmlformats.org/presentationml/2006/main">
   <p:sldMasterIdLst>
-    <p:sldMasterId xmlns:r="http://schemas.openxmlformats.org/officeDocument/2006/relationships" id="2147483648" r:id="R0c3f4fe63ea04586"/>
+    <p:sldMasterId xmlns:r="http://schemas.openxmlformats.org/officeDocument/2006/relationships" id="2147483648" r:id="Rd4a4a6cdc4434ee0"/>
   </p:sldMasterIdLst>
   <p:notesMasterIdLst>
-    <p:notesMasterId xmlns:r="http://schemas.openxmlformats.org/officeDocument/2006/relationships" r:id="Ra413cbe6afa84164"/>
+    <p:notesMasterId xmlns:r="http://schemas.openxmlformats.org/officeDocument/2006/relationships" r:id="R54e49a45bd1b4d88"/>
   </p:notesMasterIdLst>
   <p:sldIdLst>
-    <p:sldId xmlns:r="http://schemas.openxmlformats.org/officeDocument/2006/relationships" id="256" r:id="Rd6c09bcb34754d5a"/>
-    <p:sldId xmlns:r="http://schemas.openxmlformats.org/officeDocument/2006/relationships" id="257" r:id="R7376dffbc42047b7"/>
-    <p:sldId xmlns:r="http://schemas.openxmlformats.org/officeDocument/2006/relationships" id="258" r:id="Re5c93c849128460b"/>
-    <p:sldId xmlns:r="http://schemas.openxmlformats.org/officeDocument/2006/relationships" id="259" r:id="R6dd2c30e4b8a4ad4"/>
-    <p:sldId xmlns:r="http://schemas.openxmlformats.org/officeDocument/2006/relationships" id="260" r:id="R636df922dea649b2"/>
-    <p:sldId xmlns:r="http://schemas.openxmlformats.org/officeDocument/2006/relationships" id="261" r:id="R824c9507610647ac"/>
-    <p:sldId xmlns:r="http://schemas.openxmlformats.org/officeDocument/2006/relationships" id="262" r:id="R2797e41e298d4044"/>
-    <p:sldId xmlns:r="http://schemas.openxmlformats.org/officeDocument/2006/relationships" id="263" r:id="Rad8149b6b81f42d3"/>
-    <p:sldId xmlns:r="http://schemas.openxmlformats.org/officeDocument/2006/relationships" id="264" r:id="R608a9fe242424378"/>
-    <p:sldId xmlns:r="http://schemas.openxmlformats.org/officeDocument/2006/relationships" id="265" r:id="Re7d5f6f87d994bce"/>
+    <p:sldId xmlns:r="http://schemas.openxmlformats.org/officeDocument/2006/relationships" id="256" r:id="Rc55d2dae5da346f9"/>
+    <p:sldId xmlns:r="http://schemas.openxmlformats.org/officeDocument/2006/relationships" id="257" r:id="Rd0161f1a86324e7c"/>
+    <p:sldId xmlns:r="http://schemas.openxmlformats.org/officeDocument/2006/relationships" id="258" r:id="R2aa54f7e85b34425"/>
+    <p:sldId xmlns:r="http://schemas.openxmlformats.org/officeDocument/2006/relationships" id="259" r:id="Rf2d4a4384a434a77"/>
+    <p:sldId xmlns:r="http://schemas.openxmlformats.org/officeDocument/2006/relationships" id="260" r:id="Re0c53f9a07634495"/>
+    <p:sldId xmlns:r="http://schemas.openxmlformats.org/officeDocument/2006/relationships" id="261" r:id="R55fb3cac46794274"/>
+    <p:sldId xmlns:r="http://schemas.openxmlformats.org/officeDocument/2006/relationships" id="262" r:id="Rd98fe14cea53497c"/>
+    <p:sldId xmlns:r="http://schemas.openxmlformats.org/officeDocument/2006/relationships" id="263" r:id="R74a50880471b4848"/>
+    <p:sldId xmlns:r="http://schemas.openxmlformats.org/officeDocument/2006/relationships" id="264" r:id="R8d4fe22f85d24523"/>
+    <p:sldId xmlns:r="http://schemas.openxmlformats.org/officeDocument/2006/relationships" id="265" r:id="R9b70fcae2197455a"/>
   </p:sldIdLst>
   <p:sldSz cx="12192000" cy="6858000"/>
   <p:notesSz cx="6858000" cy="9144000"/>
@@ -1149,7 +1149,7 @@
   </p:cSld>
   <p:clrMap bg1="lt1" tx1="dk1" bg2="lt2" tx2="dk2" accent1="accent1" accent2="accent2" accent3="accent3" accent4="accent4" accent5="accent5" accent6="accent6" hlink="hlink" folHlink="folHlink"/>
   <p:sldLayoutIdLst>
-    <p:sldLayoutId xmlns:r="http://schemas.openxmlformats.org/officeDocument/2006/relationships" id="2147483649" r:id="Rd8835c28c8794da0"/>
+    <p:sldLayoutId xmlns:r="http://schemas.openxmlformats.org/officeDocument/2006/relationships" id="2147483649" r:id="R8a3a50e2e54143ec"/>
   </p:sldLayoutIdLst>
   <p:txStyles>
     <p:titleStyle>
@@ -1700,7 +1700,7 @@
           <p:cNvPr id="8" name="slide-number">
             <a:extLst xmlns:a="http://schemas.openxmlformats.org/drawingml/2006/main">
               <a:ext uri="{FF2B5EF4-FFF2-40B4-BE49-F238E27FC236}">
-                <a16:creationId xmlns:a16="http://schemas.microsoft.com/office/drawing/2014/main" id="{40907753-EE67-4220-963F-6331F9406058}"/>
+                <a16:creationId xmlns:a16="http://schemas.microsoft.com/office/drawing/2014/main" id="{492DE73A-0931-4DF0-B638-E78D03857ABB}"/>
               </a:ext>
             </a:extLst>
           </p:cNvPr>
@@ -1761,7 +1761,7 @@
           <p:cNvPr id="2" name="section-label">
             <a:extLst xmlns:a="http://schemas.openxmlformats.org/drawingml/2006/main">
               <a:ext uri="{FF2B5EF4-FFF2-40B4-BE49-F238E27FC236}">
-                <a16:creationId xmlns:a16="http://schemas.microsoft.com/office/drawing/2014/main" id="{8B13A844-07D2-4962-A3F3-6F2607108F34}"/>
+                <a16:creationId xmlns:a16="http://schemas.microsoft.com/office/drawing/2014/main" id="{3C89E49E-2098-454A-9B0C-5DDBBD3A514A}"/>
               </a:ext>
             </a:extLst>
           </p:cNvPr>
@@ -1822,7 +1822,7 @@
           <p:cNvPr id="3" name="headline">
             <a:extLst xmlns:a="http://schemas.openxmlformats.org/drawingml/2006/main">
               <a:ext uri="{FF2B5EF4-FFF2-40B4-BE49-F238E27FC236}">
-                <a16:creationId xmlns:a16="http://schemas.microsoft.com/office/drawing/2014/main" id="{A6DA54E9-8A29-4110-B824-B902786AC8CD}"/>
+                <a16:creationId xmlns:a16="http://schemas.microsoft.com/office/drawing/2014/main" id="{A1051729-87CD-4B5D-915A-189732A894EA}"/>
               </a:ext>
             </a:extLst>
           </p:cNvPr>
@@ -1910,7 +1910,7 @@
           <p:cNvPr id="4" name="cover-intro">
             <a:extLst xmlns:a="http://schemas.openxmlformats.org/drawingml/2006/main">
               <a:ext uri="{FF2B5EF4-FFF2-40B4-BE49-F238E27FC236}">
-                <a16:creationId xmlns:a16="http://schemas.microsoft.com/office/drawing/2014/main" id="{65D56102-0C04-4968-A36E-2D38F2E0A95C}"/>
+                <a16:creationId xmlns:a16="http://schemas.microsoft.com/office/drawing/2014/main" id="{C38A2793-DDE7-40B3-8B7D-8DA4C98027C0}"/>
               </a:ext>
             </a:extLst>
           </p:cNvPr>
@@ -1998,7 +1998,7 @@
           <p:cNvPr id="5" name="cover-accent">
             <a:extLst xmlns:a="http://schemas.openxmlformats.org/drawingml/2006/main">
               <a:ext uri="{FF2B5EF4-FFF2-40B4-BE49-F238E27FC236}">
-                <a16:creationId xmlns:a16="http://schemas.microsoft.com/office/drawing/2014/main" id="{228DA647-0932-4AC7-A2D7-C1864DCAAF8D}"/>
+                <a16:creationId xmlns:a16="http://schemas.microsoft.com/office/drawing/2014/main" id="{38682704-A57D-4AF6-BF13-D9031F1ACD20}"/>
               </a:ext>
             </a:extLst>
           </p:cNvPr>
@@ -2028,7 +2028,7 @@
           <p:cNvPr id="6" name="cover-type">
             <a:extLst xmlns:a="http://schemas.openxmlformats.org/drawingml/2006/main">
               <a:ext uri="{FF2B5EF4-FFF2-40B4-BE49-F238E27FC236}">
-                <a16:creationId xmlns:a16="http://schemas.microsoft.com/office/drawing/2014/main" id="{14C78FF0-7BEE-40C7-99B5-F1883DB2E32E}"/>
+                <a16:creationId xmlns:a16="http://schemas.microsoft.com/office/drawing/2014/main" id="{B7C11EB2-DFE4-4C9E-8DB5-EA1671C71F91}"/>
               </a:ext>
             </a:extLst>
           </p:cNvPr>
@@ -2093,7 +2093,7 @@
           <p:nvPr/>
         </p:nvPicPr>
         <p:blipFill>
-          <a:blip xmlns:r="http://schemas.openxmlformats.org/officeDocument/2006/relationships" xmlns:a="http://schemas.openxmlformats.org/drawingml/2006/main" r:embed="R7682588021274aa6"/>
+          <a:blip xmlns:r="http://schemas.openxmlformats.org/officeDocument/2006/relationships" xmlns:a="http://schemas.openxmlformats.org/drawingml/2006/main" r:embed="R46d41c84d1d64525"/>
           <a:stretch xmlns:a="http://schemas.openxmlformats.org/drawingml/2006/main"/>
         </p:blipFill>
         <p:spPr>
@@ -2109,7 +2109,7 @@
     </p:spTree>
     <p:extLst>
       <p:ext uri="{BB962C8B-B14F-4D97-AF65-F5344CB8AC3E}">
-        <p14:creationId xmlns:p14="http://schemas.microsoft.com/office/powerpoint/2010/main" val="1195653687"/>
+        <p14:creationId xmlns:p14="http://schemas.microsoft.com/office/powerpoint/2010/main" val="127214222"/>
       </p:ext>
     </p:extLst>
   </p:cSld>
@@ -2140,7 +2140,7 @@
           <p:cNvPr id="7" name="slide-number">
             <a:extLst xmlns:a="http://schemas.openxmlformats.org/drawingml/2006/main">
               <a:ext uri="{FF2B5EF4-FFF2-40B4-BE49-F238E27FC236}">
-                <a16:creationId xmlns:a16="http://schemas.microsoft.com/office/drawing/2014/main" id="{FF221CA9-255C-404B-AE73-ED3F171E1A8D}"/>
+                <a16:creationId xmlns:a16="http://schemas.microsoft.com/office/drawing/2014/main" id="{33DA02CC-7D93-4C40-8E3C-33CD347FD86B}"/>
               </a:ext>
             </a:extLst>
           </p:cNvPr>
@@ -2201,7 +2201,7 @@
           <p:cNvPr id="2" name="section-label">
             <a:extLst xmlns:a="http://schemas.openxmlformats.org/drawingml/2006/main">
               <a:ext uri="{FF2B5EF4-FFF2-40B4-BE49-F238E27FC236}">
-                <a16:creationId xmlns:a16="http://schemas.microsoft.com/office/drawing/2014/main" id="{F655188D-D30F-432E-837E-E3DD2DA20DE0}"/>
+                <a16:creationId xmlns:a16="http://schemas.microsoft.com/office/drawing/2014/main" id="{2B60DB53-B8D4-4417-B748-57850CB6C055}"/>
               </a:ext>
             </a:extLst>
           </p:cNvPr>
@@ -2262,7 +2262,7 @@
           <p:cNvPr id="3" name="headline">
             <a:extLst xmlns:a="http://schemas.openxmlformats.org/drawingml/2006/main">
               <a:ext uri="{FF2B5EF4-FFF2-40B4-BE49-F238E27FC236}">
-                <a16:creationId xmlns:a16="http://schemas.microsoft.com/office/drawing/2014/main" id="{546DCCD8-14AF-4357-B3F9-0C980992345B}"/>
+                <a16:creationId xmlns:a16="http://schemas.microsoft.com/office/drawing/2014/main" id="{21C6EA93-3006-41D2-B301-6986DEBA6298}"/>
               </a:ext>
             </a:extLst>
           </p:cNvPr>
@@ -2350,7 +2350,7 @@
           <p:cNvPr id="4" name="contact-intent">
             <a:extLst xmlns:a="http://schemas.openxmlformats.org/drawingml/2006/main">
               <a:ext uri="{FF2B5EF4-FFF2-40B4-BE49-F238E27FC236}">
-                <a16:creationId xmlns:a16="http://schemas.microsoft.com/office/drawing/2014/main" id="{F5735855-6BD3-4D17-B5CB-E9020F44EDCD}"/>
+                <a16:creationId xmlns:a16="http://schemas.microsoft.com/office/drawing/2014/main" id="{A7B82F83-C224-4802-814B-1CF06E64E1DF}"/>
               </a:ext>
             </a:extLst>
           </p:cNvPr>
@@ -2411,7 +2411,7 @@
           <p:cNvPr id="5" name="email">
             <a:extLst xmlns:a="http://schemas.openxmlformats.org/drawingml/2006/main">
               <a:ext uri="{FF2B5EF4-FFF2-40B4-BE49-F238E27FC236}">
-                <a16:creationId xmlns:a16="http://schemas.microsoft.com/office/drawing/2014/main" id="{22B337B1-2931-44CF-951B-8CA67E373738}"/>
+                <a16:creationId xmlns:a16="http://schemas.microsoft.com/office/drawing/2014/main" id="{3F2E2C04-D732-46C4-AB44-C693BCD7222B}"/>
               </a:ext>
             </a:extLst>
           </p:cNvPr>
@@ -2461,7 +2461,7 @@
                 <a:latin typeface="Helvetica Neue"/>
                 <a:ea typeface="Helvetica Neue"/>
                 <a:cs typeface="Helvetica Neue"/>
-                <a:hlinkClick xmlns:r="http://schemas.openxmlformats.org/officeDocument/2006/relationships" r:id="R18253624faa6421a"/>
+                <a:hlinkClick xmlns:r="http://schemas.openxmlformats.org/officeDocument/2006/relationships" r:id="Rbec667ab4ce3484e"/>
               </a:rPr>
               <a:t>JonathanKyleHobson@gmail.com</a:t>
             </a:r>
@@ -2473,7 +2473,7 @@
           <p:cNvPr id="6" name="public-profile">
             <a:extLst xmlns:a="http://schemas.openxmlformats.org/drawingml/2006/main">
               <a:ext uri="{FF2B5EF4-FFF2-40B4-BE49-F238E27FC236}">
-                <a16:creationId xmlns:a16="http://schemas.microsoft.com/office/drawing/2014/main" id="{8D24133D-C292-459C-B2D7-FBF505751638}"/>
+                <a16:creationId xmlns:a16="http://schemas.microsoft.com/office/drawing/2014/main" id="{E49186DC-4498-4C42-A16C-B5F9BF4691BA}"/>
               </a:ext>
             </a:extLst>
           </p:cNvPr>
@@ -2523,7 +2523,7 @@
                 <a:latin typeface="Helvetica Neue"/>
                 <a:ea typeface="Helvetica Neue"/>
                 <a:cs typeface="Helvetica Neue"/>
-                <a:hlinkClick xmlns:r="http://schemas.openxmlformats.org/officeDocument/2006/relationships" r:id="R86d7044058e54587"/>
+                <a:hlinkClick xmlns:r="http://schemas.openxmlformats.org/officeDocument/2006/relationships" r:id="Rc99a5a53ca064438"/>
               </a:rPr>
               <a:t>jonathankhobson.github.io/portfolio/design</a:t>
             </a:r>
@@ -2533,7 +2533,7 @@
     </p:spTree>
     <p:extLst>
       <p:ext uri="{BB962C8B-B14F-4D97-AF65-F5344CB8AC3E}">
-        <p14:creationId xmlns:p14="http://schemas.microsoft.com/office/powerpoint/2010/main" val="1057773241"/>
+        <p14:creationId xmlns:p14="http://schemas.microsoft.com/office/powerpoint/2010/main" val="812961590"/>
       </p:ext>
     </p:extLst>
   </p:cSld>
@@ -2564,7 +2564,7 @@
           <p:cNvPr id="10" name="slide-number">
             <a:extLst xmlns:a="http://schemas.openxmlformats.org/drawingml/2006/main">
               <a:ext uri="{FF2B5EF4-FFF2-40B4-BE49-F238E27FC236}">
-                <a16:creationId xmlns:a16="http://schemas.microsoft.com/office/drawing/2014/main" id="{37BB7302-95D7-46E0-A8EC-535A66D9B489}"/>
+                <a16:creationId xmlns:a16="http://schemas.microsoft.com/office/drawing/2014/main" id="{745AA609-2CA9-4007-9B7A-CBFC4D69F578}"/>
               </a:ext>
             </a:extLst>
           </p:cNvPr>
@@ -2625,7 +2625,7 @@
           <p:cNvPr id="2" name="section-label">
             <a:extLst xmlns:a="http://schemas.openxmlformats.org/drawingml/2006/main">
               <a:ext uri="{FF2B5EF4-FFF2-40B4-BE49-F238E27FC236}">
-                <a16:creationId xmlns:a16="http://schemas.microsoft.com/office/drawing/2014/main" id="{0FF20F1E-2B9A-4542-AB75-33581569725B}"/>
+                <a16:creationId xmlns:a16="http://schemas.microsoft.com/office/drawing/2014/main" id="{700C287C-5FFC-40C5-ABDE-101BBF3FD22E}"/>
               </a:ext>
             </a:extLst>
           </p:cNvPr>
@@ -2686,7 +2686,7 @@
           <p:cNvPr id="3" name="headline">
             <a:extLst xmlns:a="http://schemas.openxmlformats.org/drawingml/2006/main">
               <a:ext uri="{FF2B5EF4-FFF2-40B4-BE49-F238E27FC236}">
-                <a16:creationId xmlns:a16="http://schemas.microsoft.com/office/drawing/2014/main" id="{B5AC6483-8772-451E-87B1-6C2686DCEA12}"/>
+                <a16:creationId xmlns:a16="http://schemas.microsoft.com/office/drawing/2014/main" id="{2E02C282-88BE-4257-BD76-875E363D018A}"/>
               </a:ext>
             </a:extLst>
           </p:cNvPr>
@@ -2774,7 +2774,7 @@
           <p:cNvPr id="4" name="role">
             <a:extLst xmlns:a="http://schemas.openxmlformats.org/drawingml/2006/main">
               <a:ext uri="{FF2B5EF4-FFF2-40B4-BE49-F238E27FC236}">
-                <a16:creationId xmlns:a16="http://schemas.microsoft.com/office/drawing/2014/main" id="{BF0E2209-87E1-4425-AD99-97BD78614053}"/>
+                <a16:creationId xmlns:a16="http://schemas.microsoft.com/office/drawing/2014/main" id="{D2476ED9-8D8D-45EA-98A0-C4CCE6EF4CD0}"/>
               </a:ext>
             </a:extLst>
           </p:cNvPr>
@@ -2862,7 +2862,7 @@
           <p:cNvPr id="5" name="entry-decision">
             <a:extLst xmlns:a="http://schemas.openxmlformats.org/drawingml/2006/main">
               <a:ext uri="{FF2B5EF4-FFF2-40B4-BE49-F238E27FC236}">
-                <a16:creationId xmlns:a16="http://schemas.microsoft.com/office/drawing/2014/main" id="{EADBE31C-C9BD-4ECD-8B4D-F91FE2388BE8}"/>
+                <a16:creationId xmlns:a16="http://schemas.microsoft.com/office/drawing/2014/main" id="{964767E5-4B96-412C-9AAE-3835443136A6}"/>
               </a:ext>
             </a:extLst>
           </p:cNvPr>
@@ -2923,7 +2923,7 @@
           <p:cNvPr id="6" name="stage">
             <a:extLst xmlns:a="http://schemas.openxmlformats.org/drawingml/2006/main">
               <a:ext uri="{FF2B5EF4-FFF2-40B4-BE49-F238E27FC236}">
-                <a16:creationId xmlns:a16="http://schemas.microsoft.com/office/drawing/2014/main" id="{59738784-C14D-4678-B609-2154AAB011A7}"/>
+                <a16:creationId xmlns:a16="http://schemas.microsoft.com/office/drawing/2014/main" id="{CD598423-7149-4D3C-A1F2-F34ED4680DD9}"/>
               </a:ext>
             </a:extLst>
           </p:cNvPr>
@@ -2984,7 +2984,7 @@
           <p:cNvPr id="7" name="entry-scope">
             <a:extLst xmlns:a="http://schemas.openxmlformats.org/drawingml/2006/main">
               <a:ext uri="{FF2B5EF4-FFF2-40B4-BE49-F238E27FC236}">
-                <a16:creationId xmlns:a16="http://schemas.microsoft.com/office/drawing/2014/main" id="{92EA0FD6-9BE4-4F82-913A-7E8BCF2D30AD}"/>
+                <a16:creationId xmlns:a16="http://schemas.microsoft.com/office/drawing/2014/main" id="{FFBD44B0-BA71-490E-90E1-D6C939D37258}"/>
               </a:ext>
             </a:extLst>
           </p:cNvPr>
@@ -3045,7 +3045,7 @@
           <p:cNvPr id="8" name="phone-surface">
             <a:extLst xmlns:a="http://schemas.openxmlformats.org/drawingml/2006/main">
               <a:ext uri="{FF2B5EF4-FFF2-40B4-BE49-F238E27FC236}">
-                <a16:creationId xmlns:a16="http://schemas.microsoft.com/office/drawing/2014/main" id="{773FFF75-5C0F-4BE5-8D41-FC35BC698125}"/>
+                <a16:creationId xmlns:a16="http://schemas.microsoft.com/office/drawing/2014/main" id="{89C8B721-FE91-49CF-BC3D-D3E65F0897F9}"/>
               </a:ext>
             </a:extLst>
           </p:cNvPr>
@@ -3079,7 +3079,7 @@
           <p:nvPr/>
         </p:nvPicPr>
         <p:blipFill>
-          <a:blip xmlns:r="http://schemas.openxmlformats.org/officeDocument/2006/relationships" xmlns:a="http://schemas.openxmlformats.org/drawingml/2006/main" r:embed="R3a2f1444a43443fc"/>
+          <a:blip xmlns:r="http://schemas.openxmlformats.org/officeDocument/2006/relationships" xmlns:a="http://schemas.openxmlformats.org/drawingml/2006/main" r:embed="R08722bb7f8ed4c41"/>
           <a:stretch xmlns:a="http://schemas.openxmlformats.org/drawingml/2006/main"/>
         </p:blipFill>
         <p:spPr>
@@ -3095,7 +3095,7 @@
     </p:spTree>
     <p:extLst>
       <p:ext uri="{BB962C8B-B14F-4D97-AF65-F5344CB8AC3E}">
-        <p14:creationId xmlns:p14="http://schemas.microsoft.com/office/powerpoint/2010/main" val="1857698077"/>
+        <p14:creationId xmlns:p14="http://schemas.microsoft.com/office/powerpoint/2010/main" val="122957110"/>
       </p:ext>
     </p:extLst>
   </p:cSld>
@@ -3126,7 +3126,7 @@
           <p:cNvPr id="9" name="slide-number">
             <a:extLst xmlns:a="http://schemas.openxmlformats.org/drawingml/2006/main">
               <a:ext uri="{FF2B5EF4-FFF2-40B4-BE49-F238E27FC236}">
-                <a16:creationId xmlns:a16="http://schemas.microsoft.com/office/drawing/2014/main" id="{E3F7DCF9-5CA5-46F6-ADFA-ADE9C4771048}"/>
+                <a16:creationId xmlns:a16="http://schemas.microsoft.com/office/drawing/2014/main" id="{1236A8A2-5FD9-47BC-9E19-3905AE09D3A3}"/>
               </a:ext>
             </a:extLst>
           </p:cNvPr>
@@ -3187,7 +3187,7 @@
           <p:cNvPr id="2" name="section-label">
             <a:extLst xmlns:a="http://schemas.openxmlformats.org/drawingml/2006/main">
               <a:ext uri="{FF2B5EF4-FFF2-40B4-BE49-F238E27FC236}">
-                <a16:creationId xmlns:a16="http://schemas.microsoft.com/office/drawing/2014/main" id="{77EE1F14-B886-4EF5-B432-AD48112028D7}"/>
+                <a16:creationId xmlns:a16="http://schemas.microsoft.com/office/drawing/2014/main" id="{08D28B54-86F1-4FDD-9684-DCA0024BCAB1}"/>
               </a:ext>
             </a:extLst>
           </p:cNvPr>
@@ -3248,7 +3248,7 @@
           <p:cNvPr id="3" name="headline">
             <a:extLst xmlns:a="http://schemas.openxmlformats.org/drawingml/2006/main">
               <a:ext uri="{FF2B5EF4-FFF2-40B4-BE49-F238E27FC236}">
-                <a16:creationId xmlns:a16="http://schemas.microsoft.com/office/drawing/2014/main" id="{F1EB944A-56E7-4215-8A50-2D676630B766}"/>
+                <a16:creationId xmlns:a16="http://schemas.microsoft.com/office/drawing/2014/main" id="{7CF3A88A-C1A7-4AA4-AB38-E6DCA3AE351D}"/>
               </a:ext>
             </a:extLst>
           </p:cNvPr>
@@ -3336,7 +3336,7 @@
           <p:cNvPr id="4" name="waiting-decision">
             <a:extLst xmlns:a="http://schemas.openxmlformats.org/drawingml/2006/main">
               <a:ext uri="{FF2B5EF4-FFF2-40B4-BE49-F238E27FC236}">
-                <a16:creationId xmlns:a16="http://schemas.microsoft.com/office/drawing/2014/main" id="{153209C4-3AA7-4762-8D6B-5B14B2A33184}"/>
+                <a16:creationId xmlns:a16="http://schemas.microsoft.com/office/drawing/2014/main" id="{5C8DF091-82B2-41F3-8BDD-337715CA66BD}"/>
               </a:ext>
             </a:extLst>
           </p:cNvPr>
@@ -3397,7 +3397,7 @@
           <p:cNvPr id="5" name="waiting-constraint">
             <a:extLst xmlns:a="http://schemas.openxmlformats.org/drawingml/2006/main">
               <a:ext uri="{FF2B5EF4-FFF2-40B4-BE49-F238E27FC236}">
-                <a16:creationId xmlns:a16="http://schemas.microsoft.com/office/drawing/2014/main" id="{A22F90BF-8AED-442D-A0A1-14FE09FCF0F0}"/>
+                <a16:creationId xmlns:a16="http://schemas.microsoft.com/office/drawing/2014/main" id="{2726AC3B-9CCE-471F-B524-7EFCE813ED15}"/>
               </a:ext>
             </a:extLst>
           </p:cNvPr>
@@ -3462,7 +3462,7 @@
           <p:nvPr/>
         </p:nvPicPr>
         <p:blipFill>
-          <a:blip xmlns:r="http://schemas.openxmlformats.org/officeDocument/2006/relationships" xmlns:a="http://schemas.openxmlformats.org/drawingml/2006/main" r:embed="R637729a816694be8"/>
+          <a:blip xmlns:r="http://schemas.openxmlformats.org/officeDocument/2006/relationships" xmlns:a="http://schemas.openxmlformats.org/drawingml/2006/main" r:embed="Rfefdc1112d4e4521"/>
           <a:stretch xmlns:a="http://schemas.openxmlformats.org/drawingml/2006/main"/>
         </p:blipFill>
         <p:spPr>
@@ -3480,7 +3480,7 @@
           <p:cNvPr id="7" name="detail-caption">
             <a:extLst xmlns:a="http://schemas.openxmlformats.org/drawingml/2006/main">
               <a:ext uri="{FF2B5EF4-FFF2-40B4-BE49-F238E27FC236}">
-                <a16:creationId xmlns:a16="http://schemas.microsoft.com/office/drawing/2014/main" id="{A7B42DAB-792F-4814-8A19-265F1518D89C}"/>
+                <a16:creationId xmlns:a16="http://schemas.microsoft.com/office/drawing/2014/main" id="{1453D508-F74E-4661-9647-0043F53EE4E5}"/>
               </a:ext>
             </a:extLst>
           </p:cNvPr>
@@ -3545,7 +3545,7 @@
           <p:nvPr/>
         </p:nvPicPr>
         <p:blipFill>
-          <a:blip xmlns:r="http://schemas.openxmlformats.org/officeDocument/2006/relationships" xmlns:a="http://schemas.openxmlformats.org/drawingml/2006/main" r:embed="R33ef4f25a8664d53"/>
+          <a:blip xmlns:r="http://schemas.openxmlformats.org/officeDocument/2006/relationships" xmlns:a="http://schemas.openxmlformats.org/drawingml/2006/main" r:embed="R018ac03db71e42fb"/>
           <a:stretch xmlns:a="http://schemas.openxmlformats.org/drawingml/2006/main"/>
         </p:blipFill>
         <p:spPr>
@@ -3561,7 +3561,7 @@
     </p:spTree>
     <p:extLst>
       <p:ext uri="{BB962C8B-B14F-4D97-AF65-F5344CB8AC3E}">
-        <p14:creationId xmlns:p14="http://schemas.microsoft.com/office/powerpoint/2010/main" val="280712050"/>
+        <p14:creationId xmlns:p14="http://schemas.microsoft.com/office/powerpoint/2010/main" val="1424311719"/>
       </p:ext>
     </p:extLst>
   </p:cSld>
@@ -3592,7 +3592,7 @@
           <p:cNvPr id="10" name="slide-number">
             <a:extLst xmlns:a="http://schemas.openxmlformats.org/drawingml/2006/main">
               <a:ext uri="{FF2B5EF4-FFF2-40B4-BE49-F238E27FC236}">
-                <a16:creationId xmlns:a16="http://schemas.microsoft.com/office/drawing/2014/main" id="{60ABFD67-EFA2-47C0-B8D2-F4B17F353770}"/>
+                <a16:creationId xmlns:a16="http://schemas.microsoft.com/office/drawing/2014/main" id="{9ED8A18E-B1B5-4A51-B27B-76E585B5C355}"/>
               </a:ext>
             </a:extLst>
           </p:cNvPr>
@@ -3653,7 +3653,7 @@
           <p:cNvPr id="2" name="section-label">
             <a:extLst xmlns:a="http://schemas.openxmlformats.org/drawingml/2006/main">
               <a:ext uri="{FF2B5EF4-FFF2-40B4-BE49-F238E27FC236}">
-                <a16:creationId xmlns:a16="http://schemas.microsoft.com/office/drawing/2014/main" id="{1B28E4CC-57C2-42A8-AC94-816EF09725AC}"/>
+                <a16:creationId xmlns:a16="http://schemas.microsoft.com/office/drawing/2014/main" id="{CAF097C2-CF62-4FDF-A614-4A9D539A1004}"/>
               </a:ext>
             </a:extLst>
           </p:cNvPr>
@@ -3714,7 +3714,7 @@
           <p:cNvPr id="3" name="headline">
             <a:extLst xmlns:a="http://schemas.openxmlformats.org/drawingml/2006/main">
               <a:ext uri="{FF2B5EF4-FFF2-40B4-BE49-F238E27FC236}">
-                <a16:creationId xmlns:a16="http://schemas.microsoft.com/office/drawing/2014/main" id="{1A230DE5-7E5C-4987-8659-C3870D8A35A9}"/>
+                <a16:creationId xmlns:a16="http://schemas.microsoft.com/office/drawing/2014/main" id="{2C5752DD-3752-4106-B06E-0605583D20CB}"/>
               </a:ext>
             </a:extLst>
           </p:cNvPr>
@@ -3802,7 +3802,7 @@
           <p:cNvPr id="4" name="recovery-decision">
             <a:extLst xmlns:a="http://schemas.openxmlformats.org/drawingml/2006/main">
               <a:ext uri="{FF2B5EF4-FFF2-40B4-BE49-F238E27FC236}">
-                <a16:creationId xmlns:a16="http://schemas.microsoft.com/office/drawing/2014/main" id="{0F7D635C-7136-442F-AD49-3214F78E71BB}"/>
+                <a16:creationId xmlns:a16="http://schemas.microsoft.com/office/drawing/2014/main" id="{F833A5E3-747E-4211-ABEA-A70EABC3F248}"/>
               </a:ext>
             </a:extLst>
           </p:cNvPr>
@@ -3863,7 +3863,7 @@
           <p:cNvPr id="5" name="recovery-outcome">
             <a:extLst xmlns:a="http://schemas.openxmlformats.org/drawingml/2006/main">
               <a:ext uri="{FF2B5EF4-FFF2-40B4-BE49-F238E27FC236}">
-                <a16:creationId xmlns:a16="http://schemas.microsoft.com/office/drawing/2014/main" id="{1AA72024-190B-4C62-9E45-892CC7D169D5}"/>
+                <a16:creationId xmlns:a16="http://schemas.microsoft.com/office/drawing/2014/main" id="{9BF1DBAE-5109-4B35-9E97-DDAE66987BEB}"/>
               </a:ext>
             </a:extLst>
           </p:cNvPr>
@@ -3924,7 +3924,7 @@
           <p:cNvPr id="6" name="incomplete-label">
             <a:extLst xmlns:a="http://schemas.openxmlformats.org/drawingml/2006/main">
               <a:ext uri="{FF2B5EF4-FFF2-40B4-BE49-F238E27FC236}">
-                <a16:creationId xmlns:a16="http://schemas.microsoft.com/office/drawing/2014/main" id="{03D0F967-2B39-4483-8E36-6C91E7185F78}"/>
+                <a16:creationId xmlns:a16="http://schemas.microsoft.com/office/drawing/2014/main" id="{7AB5C320-C73C-44F1-91AE-0A85EDF68552}"/>
               </a:ext>
             </a:extLst>
           </p:cNvPr>
@@ -3985,7 +3985,7 @@
           <p:cNvPr id="7" name="offline-label">
             <a:extLst xmlns:a="http://schemas.openxmlformats.org/drawingml/2006/main">
               <a:ext uri="{FF2B5EF4-FFF2-40B4-BE49-F238E27FC236}">
-                <a16:creationId xmlns:a16="http://schemas.microsoft.com/office/drawing/2014/main" id="{A9085755-E434-401E-877B-E300A9A7BD49}"/>
+                <a16:creationId xmlns:a16="http://schemas.microsoft.com/office/drawing/2014/main" id="{115336CE-F44F-45E6-8FF8-9E09E6C9A103}"/>
               </a:ext>
             </a:extLst>
           </p:cNvPr>
@@ -4050,7 +4050,7 @@
           <p:nvPr/>
         </p:nvPicPr>
         <p:blipFill>
-          <a:blip xmlns:r="http://schemas.openxmlformats.org/officeDocument/2006/relationships" xmlns:a="http://schemas.openxmlformats.org/drawingml/2006/main" r:embed="R63076d0d1fca4e59"/>
+          <a:blip xmlns:r="http://schemas.openxmlformats.org/officeDocument/2006/relationships" xmlns:a="http://schemas.openxmlformats.org/drawingml/2006/main" r:embed="R495b209980f54a99"/>
           <a:stretch xmlns:a="http://schemas.openxmlformats.org/drawingml/2006/main"/>
         </p:blipFill>
         <p:spPr>
@@ -4072,7 +4072,7 @@
           <p:nvPr/>
         </p:nvPicPr>
         <p:blipFill>
-          <a:blip xmlns:r="http://schemas.openxmlformats.org/officeDocument/2006/relationships" xmlns:a="http://schemas.openxmlformats.org/drawingml/2006/main" r:embed="R4e19fe8ee8c041af"/>
+          <a:blip xmlns:r="http://schemas.openxmlformats.org/officeDocument/2006/relationships" xmlns:a="http://schemas.openxmlformats.org/drawingml/2006/main" r:embed="R552dfe2e8cc64c0a"/>
           <a:stretch xmlns:a="http://schemas.openxmlformats.org/drawingml/2006/main"/>
         </p:blipFill>
         <p:spPr>
@@ -4088,7 +4088,7 @@
     </p:spTree>
     <p:extLst>
       <p:ext uri="{BB962C8B-B14F-4D97-AF65-F5344CB8AC3E}">
-        <p14:creationId xmlns:p14="http://schemas.microsoft.com/office/powerpoint/2010/main" val="654182577"/>
+        <p14:creationId xmlns:p14="http://schemas.microsoft.com/office/powerpoint/2010/main" val="268008632"/>
       </p:ext>
     </p:extLst>
   </p:cSld>
@@ -4119,7 +4119,7 @@
           <p:cNvPr id="8" name="slide-number">
             <a:extLst xmlns:a="http://schemas.openxmlformats.org/drawingml/2006/main">
               <a:ext uri="{FF2B5EF4-FFF2-40B4-BE49-F238E27FC236}">
-                <a16:creationId xmlns:a16="http://schemas.microsoft.com/office/drawing/2014/main" id="{AAF6936F-FC61-49AB-AB71-9A4706B6F68A}"/>
+                <a16:creationId xmlns:a16="http://schemas.microsoft.com/office/drawing/2014/main" id="{5E2CF711-39FB-4113-B23E-600DD14A1757}"/>
               </a:ext>
             </a:extLst>
           </p:cNvPr>
@@ -4180,7 +4180,7 @@
           <p:cNvPr id="2" name="section-label">
             <a:extLst xmlns:a="http://schemas.openxmlformats.org/drawingml/2006/main">
               <a:ext uri="{FF2B5EF4-FFF2-40B4-BE49-F238E27FC236}">
-                <a16:creationId xmlns:a16="http://schemas.microsoft.com/office/drawing/2014/main" id="{4A3E3811-0DED-4F79-AFF4-BECCF185F4FB}"/>
+                <a16:creationId xmlns:a16="http://schemas.microsoft.com/office/drawing/2014/main" id="{AE382314-AA87-4CA7-BC61-9AA94051CF69}"/>
               </a:ext>
             </a:extLst>
           </p:cNvPr>
@@ -4241,7 +4241,7 @@
           <p:cNvPr id="3" name="headline">
             <a:extLst xmlns:a="http://schemas.openxmlformats.org/drawingml/2006/main">
               <a:ext uri="{FF2B5EF4-FFF2-40B4-BE49-F238E27FC236}">
-                <a16:creationId xmlns:a16="http://schemas.microsoft.com/office/drawing/2014/main" id="{20EED95A-E8EE-46AB-BE74-FD6F8F2927EF}"/>
+                <a16:creationId xmlns:a16="http://schemas.microsoft.com/office/drawing/2014/main" id="{1A90B1DA-0D8D-4125-A4B6-B46E64269CCA}"/>
               </a:ext>
             </a:extLst>
           </p:cNvPr>
@@ -4329,7 +4329,7 @@
           <p:cNvPr id="4" name="role">
             <a:extLst xmlns:a="http://schemas.openxmlformats.org/drawingml/2006/main">
               <a:ext uri="{FF2B5EF4-FFF2-40B4-BE49-F238E27FC236}">
-                <a16:creationId xmlns:a16="http://schemas.microsoft.com/office/drawing/2014/main" id="{5F042EDF-2B1A-403E-B7DB-F853951CCA48}"/>
+                <a16:creationId xmlns:a16="http://schemas.microsoft.com/office/drawing/2014/main" id="{6B5DBAB9-BB69-429F-B468-25FB499F1EEB}"/>
               </a:ext>
             </a:extLst>
           </p:cNvPr>
@@ -4390,7 +4390,7 @@
           <p:cNvPr id="5" name="about-decision">
             <a:extLst xmlns:a="http://schemas.openxmlformats.org/drawingml/2006/main">
               <a:ext uri="{FF2B5EF4-FFF2-40B4-BE49-F238E27FC236}">
-                <a16:creationId xmlns:a16="http://schemas.microsoft.com/office/drawing/2014/main" id="{77417724-DF51-472E-848F-26164A7BFAF8}"/>
+                <a16:creationId xmlns:a16="http://schemas.microsoft.com/office/drawing/2014/main" id="{717E70D8-DF9F-4C5D-8260-E18083CAD533}"/>
               </a:ext>
             </a:extLst>
           </p:cNvPr>
@@ -4451,7 +4451,7 @@
           <p:cNvPr id="6" name="about-stage">
             <a:extLst xmlns:a="http://schemas.openxmlformats.org/drawingml/2006/main">
               <a:ext uri="{FF2B5EF4-FFF2-40B4-BE49-F238E27FC236}">
-                <a16:creationId xmlns:a16="http://schemas.microsoft.com/office/drawing/2014/main" id="{25C92173-7DE2-4D3F-97BD-D7702D26AAC8}"/>
+                <a16:creationId xmlns:a16="http://schemas.microsoft.com/office/drawing/2014/main" id="{E14CCC3B-E662-455B-B009-A8A58FBBE808}"/>
               </a:ext>
             </a:extLst>
           </p:cNvPr>
@@ -4543,7 +4543,7 @@
           <p:nvPr/>
         </p:nvPicPr>
         <p:blipFill>
-          <a:blip xmlns:r="http://schemas.openxmlformats.org/officeDocument/2006/relationships" xmlns:a="http://schemas.openxmlformats.org/drawingml/2006/main" r:embed="Radf5737f69a34b55"/>
+          <a:blip xmlns:r="http://schemas.openxmlformats.org/officeDocument/2006/relationships" xmlns:a="http://schemas.openxmlformats.org/drawingml/2006/main" r:embed="Rf395df382a34441f"/>
           <a:stretch xmlns:a="http://schemas.openxmlformats.org/drawingml/2006/main"/>
         </p:blipFill>
         <p:spPr>
@@ -4559,7 +4559,7 @@
     </p:spTree>
     <p:extLst>
       <p:ext uri="{BB962C8B-B14F-4D97-AF65-F5344CB8AC3E}">
-        <p14:creationId xmlns:p14="http://schemas.microsoft.com/office/powerpoint/2010/main" val="1996735105"/>
+        <p14:creationId xmlns:p14="http://schemas.microsoft.com/office/powerpoint/2010/main" val="915000282"/>
       </p:ext>
     </p:extLst>
   </p:cSld>
@@ -4590,7 +4590,7 @@
           <p:cNvPr id="8" name="slide-number">
             <a:extLst xmlns:a="http://schemas.openxmlformats.org/drawingml/2006/main">
               <a:ext uri="{FF2B5EF4-FFF2-40B4-BE49-F238E27FC236}">
-                <a16:creationId xmlns:a16="http://schemas.microsoft.com/office/drawing/2014/main" id="{D98E39B8-FEF3-429B-AAD6-8CD15D24089D}"/>
+                <a16:creationId xmlns:a16="http://schemas.microsoft.com/office/drawing/2014/main" id="{7A29E209-0B2F-4516-8DFF-425850D5B698}"/>
               </a:ext>
             </a:extLst>
           </p:cNvPr>
@@ -4651,7 +4651,7 @@
           <p:cNvPr id="2" name="section-label">
             <a:extLst xmlns:a="http://schemas.openxmlformats.org/drawingml/2006/main">
               <a:ext uri="{FF2B5EF4-FFF2-40B4-BE49-F238E27FC236}">
-                <a16:creationId xmlns:a16="http://schemas.microsoft.com/office/drawing/2014/main" id="{F328C108-8F07-4EE3-BEE2-12AF66595362}"/>
+                <a16:creationId xmlns:a16="http://schemas.microsoft.com/office/drawing/2014/main" id="{1BF4D6CE-E963-44C7-8754-817E72D94020}"/>
               </a:ext>
             </a:extLst>
           </p:cNvPr>
@@ -4712,7 +4712,7 @@
           <p:cNvPr id="3" name="headline">
             <a:extLst xmlns:a="http://schemas.openxmlformats.org/drawingml/2006/main">
               <a:ext uri="{FF2B5EF4-FFF2-40B4-BE49-F238E27FC236}">
-                <a16:creationId xmlns:a16="http://schemas.microsoft.com/office/drawing/2014/main" id="{837D0F28-18CD-42F0-8588-B8C010858959}"/>
+                <a16:creationId xmlns:a16="http://schemas.microsoft.com/office/drawing/2014/main" id="{13A368E2-36CB-4AE3-9801-21443B6548E9}"/>
               </a:ext>
             </a:extLst>
           </p:cNvPr>
@@ -4800,7 +4800,7 @@
           <p:cNvPr id="4" name="comparison-decision">
             <a:extLst xmlns:a="http://schemas.openxmlformats.org/drawingml/2006/main">
               <a:ext uri="{FF2B5EF4-FFF2-40B4-BE49-F238E27FC236}">
-                <a16:creationId xmlns:a16="http://schemas.microsoft.com/office/drawing/2014/main" id="{3CEB5E31-FE03-4359-934F-110B747CB88A}"/>
+                <a16:creationId xmlns:a16="http://schemas.microsoft.com/office/drawing/2014/main" id="{36D8B78A-121D-423C-BDFE-BFB9206B5683}"/>
               </a:ext>
             </a:extLst>
           </p:cNvPr>
@@ -4861,7 +4861,7 @@
           <p:cNvPr id="5" name="comparison-outcome">
             <a:extLst xmlns:a="http://schemas.openxmlformats.org/drawingml/2006/main">
               <a:ext uri="{FF2B5EF4-FFF2-40B4-BE49-F238E27FC236}">
-                <a16:creationId xmlns:a16="http://schemas.microsoft.com/office/drawing/2014/main" id="{7DE7BB39-06CD-4338-ADAB-1F0FFF737BBA}"/>
+                <a16:creationId xmlns:a16="http://schemas.microsoft.com/office/drawing/2014/main" id="{7FCEAEFD-E5FE-4FAF-B728-A9BEF89657F3}"/>
               </a:ext>
             </a:extLst>
           </p:cNvPr>
@@ -4926,7 +4926,7 @@
           <p:nvPr/>
         </p:nvPicPr>
         <p:blipFill>
-          <a:blip xmlns:r="http://schemas.openxmlformats.org/officeDocument/2006/relationships" xmlns:a="http://schemas.openxmlformats.org/drawingml/2006/main" r:embed="Rda4670abfc8e44fa"/>
+          <a:blip xmlns:r="http://schemas.openxmlformats.org/officeDocument/2006/relationships" xmlns:a="http://schemas.openxmlformats.org/drawingml/2006/main" r:embed="R8400a9e5803f44a8"/>
           <a:stretch xmlns:a="http://schemas.openxmlformats.org/drawingml/2006/main"/>
         </p:blipFill>
         <p:spPr>
@@ -4944,7 +4944,7 @@
           <p:cNvPr id="7" name="sample-label">
             <a:extLst xmlns:a="http://schemas.openxmlformats.org/drawingml/2006/main">
               <a:ext uri="{FF2B5EF4-FFF2-40B4-BE49-F238E27FC236}">
-                <a16:creationId xmlns:a16="http://schemas.microsoft.com/office/drawing/2014/main" id="{FBD04043-6F43-4E18-904E-DD2E1CC965C9}"/>
+                <a16:creationId xmlns:a16="http://schemas.microsoft.com/office/drawing/2014/main" id="{2A21790F-FDDD-4165-8FD6-239137A4C831}"/>
               </a:ext>
             </a:extLst>
           </p:cNvPr>
@@ -5003,7 +5003,7 @@
     </p:spTree>
     <p:extLst>
       <p:ext uri="{BB962C8B-B14F-4D97-AF65-F5344CB8AC3E}">
-        <p14:creationId xmlns:p14="http://schemas.microsoft.com/office/powerpoint/2010/main" val="1081454882"/>
+        <p14:creationId xmlns:p14="http://schemas.microsoft.com/office/powerpoint/2010/main" val="1894278546"/>
       </p:ext>
     </p:extLst>
   </p:cSld>
@@ -5034,7 +5034,7 @@
           <p:cNvPr id="8" name="slide-number">
             <a:extLst xmlns:a="http://schemas.openxmlformats.org/drawingml/2006/main">
               <a:ext uri="{FF2B5EF4-FFF2-40B4-BE49-F238E27FC236}">
-                <a16:creationId xmlns:a16="http://schemas.microsoft.com/office/drawing/2014/main" id="{7266A968-B762-4EF5-98CA-FDE4494FC757}"/>
+                <a16:creationId xmlns:a16="http://schemas.microsoft.com/office/drawing/2014/main" id="{7E4DA758-CF75-459A-869B-53C55E84BF82}"/>
               </a:ext>
             </a:extLst>
           </p:cNvPr>
@@ -5095,7 +5095,7 @@
           <p:cNvPr id="2" name="section-label">
             <a:extLst xmlns:a="http://schemas.openxmlformats.org/drawingml/2006/main">
               <a:ext uri="{FF2B5EF4-FFF2-40B4-BE49-F238E27FC236}">
-                <a16:creationId xmlns:a16="http://schemas.microsoft.com/office/drawing/2014/main" id="{2F3703CA-052D-4BEE-A066-8C7FD712F099}"/>
+                <a16:creationId xmlns:a16="http://schemas.microsoft.com/office/drawing/2014/main" id="{60FBD816-F314-4599-BCBC-F728BF446F5F}"/>
               </a:ext>
             </a:extLst>
           </p:cNvPr>
@@ -5156,7 +5156,7 @@
           <p:cNvPr id="3" name="headline">
             <a:extLst xmlns:a="http://schemas.openxmlformats.org/drawingml/2006/main">
               <a:ext uri="{FF2B5EF4-FFF2-40B4-BE49-F238E27FC236}">
-                <a16:creationId xmlns:a16="http://schemas.microsoft.com/office/drawing/2014/main" id="{1449FA7C-6648-4B96-AF0E-405DF8ABC0B2}"/>
+                <a16:creationId xmlns:a16="http://schemas.microsoft.com/office/drawing/2014/main" id="{FFDBC860-B2EC-4180-888B-09C0F2BD9038}"/>
               </a:ext>
             </a:extLst>
           </p:cNvPr>
@@ -5244,7 +5244,7 @@
           <p:cNvPr id="4" name="oak-observation">
             <a:extLst xmlns:a="http://schemas.openxmlformats.org/drawingml/2006/main">
               <a:ext uri="{FF2B5EF4-FFF2-40B4-BE49-F238E27FC236}">
-                <a16:creationId xmlns:a16="http://schemas.microsoft.com/office/drawing/2014/main" id="{F5C8B14C-5E34-48B1-9998-78EED26F697B}"/>
+                <a16:creationId xmlns:a16="http://schemas.microsoft.com/office/drawing/2014/main" id="{6B3D66E1-5B1E-493D-831A-491D23B037CB}"/>
               </a:ext>
             </a:extLst>
           </p:cNvPr>
@@ -5305,7 +5305,7 @@
           <p:cNvPr id="5" name="oak-rationale">
             <a:extLst xmlns:a="http://schemas.openxmlformats.org/drawingml/2006/main">
               <a:ext uri="{FF2B5EF4-FFF2-40B4-BE49-F238E27FC236}">
-                <a16:creationId xmlns:a16="http://schemas.microsoft.com/office/drawing/2014/main" id="{D0075C85-AF86-40C7-9FE1-1CEC902FE3A6}"/>
+                <a16:creationId xmlns:a16="http://schemas.microsoft.com/office/drawing/2014/main" id="{33614EEE-D16D-4FF3-A662-4B5DAA76DD59}"/>
               </a:ext>
             </a:extLst>
           </p:cNvPr>
@@ -5366,7 +5366,7 @@
           <p:cNvPr id="6" name="oak-stage">
             <a:extLst xmlns:a="http://schemas.openxmlformats.org/drawingml/2006/main">
               <a:ext uri="{FF2B5EF4-FFF2-40B4-BE49-F238E27FC236}">
-                <a16:creationId xmlns:a16="http://schemas.microsoft.com/office/drawing/2014/main" id="{D9029060-2A48-4620-9542-0BD3147115B8}"/>
+                <a16:creationId xmlns:a16="http://schemas.microsoft.com/office/drawing/2014/main" id="{D11CD25D-10A8-44F9-8E66-32E49BFD8490}"/>
               </a:ext>
             </a:extLst>
           </p:cNvPr>
@@ -5431,7 +5431,7 @@
           <p:nvPr/>
         </p:nvPicPr>
         <p:blipFill>
-          <a:blip xmlns:r="http://schemas.openxmlformats.org/officeDocument/2006/relationships" xmlns:a="http://schemas.openxmlformats.org/drawingml/2006/main" r:embed="R0522dc76a92f45d9"/>
+          <a:blip xmlns:r="http://schemas.openxmlformats.org/officeDocument/2006/relationships" xmlns:a="http://schemas.openxmlformats.org/drawingml/2006/main" r:embed="R3f427a66e89b46c8"/>
           <a:stretch xmlns:a="http://schemas.openxmlformats.org/drawingml/2006/main"/>
         </p:blipFill>
         <p:spPr>
@@ -5447,7 +5447,7 @@
     </p:spTree>
     <p:extLst>
       <p:ext uri="{BB962C8B-B14F-4D97-AF65-F5344CB8AC3E}">
-        <p14:creationId xmlns:p14="http://schemas.microsoft.com/office/powerpoint/2010/main" val="979266841"/>
+        <p14:creationId xmlns:p14="http://schemas.microsoft.com/office/powerpoint/2010/main" val="810396139"/>
       </p:ext>
     </p:extLst>
   </p:cSld>
@@ -5478,7 +5478,7 @@
           <p:cNvPr id="13" name="slide-number">
             <a:extLst xmlns:a="http://schemas.openxmlformats.org/drawingml/2006/main">
               <a:ext uri="{FF2B5EF4-FFF2-40B4-BE49-F238E27FC236}">
-                <a16:creationId xmlns:a16="http://schemas.microsoft.com/office/drawing/2014/main" id="{0EEC239C-638B-462F-99ED-51EAF44CFDB5}"/>
+                <a16:creationId xmlns:a16="http://schemas.microsoft.com/office/drawing/2014/main" id="{8D193A52-7461-49EF-A2AD-F919D665A682}"/>
               </a:ext>
             </a:extLst>
           </p:cNvPr>
@@ -5539,7 +5539,7 @@
           <p:cNvPr id="2" name="section-label">
             <a:extLst xmlns:a="http://schemas.openxmlformats.org/drawingml/2006/main">
               <a:ext uri="{FF2B5EF4-FFF2-40B4-BE49-F238E27FC236}">
-                <a16:creationId xmlns:a16="http://schemas.microsoft.com/office/drawing/2014/main" id="{DD3DB253-74F1-4276-AD22-B428D1A0BAC1}"/>
+                <a16:creationId xmlns:a16="http://schemas.microsoft.com/office/drawing/2014/main" id="{1317D2B6-2D0F-42EA-8033-FA4112BA6079}"/>
               </a:ext>
             </a:extLst>
           </p:cNvPr>
@@ -5600,7 +5600,7 @@
           <p:cNvPr id="3" name="headline">
             <a:extLst xmlns:a="http://schemas.openxmlformats.org/drawingml/2006/main">
               <a:ext uri="{FF2B5EF4-FFF2-40B4-BE49-F238E27FC236}">
-                <a16:creationId xmlns:a16="http://schemas.microsoft.com/office/drawing/2014/main" id="{58DD7D09-F02B-4909-8115-672F4A3EC76B}"/>
+                <a16:creationId xmlns:a16="http://schemas.microsoft.com/office/drawing/2014/main" id="{A3EC6DD5-D8F8-44E9-A662-4940FA2EC990}"/>
               </a:ext>
             </a:extLst>
           </p:cNvPr>
@@ -5688,7 +5688,7 @@
           <p:cNvPr id="4" name="oak-error-decision">
             <a:extLst xmlns:a="http://schemas.openxmlformats.org/drawingml/2006/main">
               <a:ext uri="{FF2B5EF4-FFF2-40B4-BE49-F238E27FC236}">
-                <a16:creationId xmlns:a16="http://schemas.microsoft.com/office/drawing/2014/main" id="{11C47E6C-4F3E-441A-A127-015AEF4B423C}"/>
+                <a16:creationId xmlns:a16="http://schemas.microsoft.com/office/drawing/2014/main" id="{D4327DB8-244E-477C-A5D1-C4DE31360DA4}"/>
               </a:ext>
             </a:extLst>
           </p:cNvPr>
@@ -5739,7 +5739,7 @@
                 <a:ea typeface="Helvetica Neue"/>
                 <a:cs typeface="Helvetica Neue"/>
               </a:rPr>
-              <a:t>I made the correction visible where a person could act on it.</a:t>
+              <a:t>I made the problem field visible where a person could act on it.</a:t>
             </a:r>
           </a:p>
         </p:txBody>
@@ -5749,7 +5749,7 @@
           <p:cNvPr id="5" name="oak-error-outcome">
             <a:extLst xmlns:a="http://schemas.openxmlformats.org/drawingml/2006/main">
               <a:ext uri="{FF2B5EF4-FFF2-40B4-BE49-F238E27FC236}">
-                <a16:creationId xmlns:a16="http://schemas.microsoft.com/office/drawing/2014/main" id="{40FF0235-3277-4835-8EBC-CF88049DA77E}"/>
+                <a16:creationId xmlns:a16="http://schemas.microsoft.com/office/drawing/2014/main" id="{05209FDC-426C-47D1-8592-8A2DC5B28247}"/>
               </a:ext>
             </a:extLst>
           </p:cNvPr>
@@ -5810,7 +5810,7 @@
           <p:cNvPr id="6" name="before-label">
             <a:extLst xmlns:a="http://schemas.openxmlformats.org/drawingml/2006/main">
               <a:ext uri="{FF2B5EF4-FFF2-40B4-BE49-F238E27FC236}">
-                <a16:creationId xmlns:a16="http://schemas.microsoft.com/office/drawing/2014/main" id="{C459A89B-70AF-4D08-A721-24D80BC7BB17}"/>
+                <a16:creationId xmlns:a16="http://schemas.microsoft.com/office/drawing/2014/main" id="{D7EF5E1B-3EBC-407A-AE7E-AE56FB2B70E0}"/>
               </a:ext>
             </a:extLst>
           </p:cNvPr>
@@ -5871,7 +5871,7 @@
           <p:cNvPr id="7" name="after-label">
             <a:extLst xmlns:a="http://schemas.openxmlformats.org/drawingml/2006/main">
               <a:ext uri="{FF2B5EF4-FFF2-40B4-BE49-F238E27FC236}">
-                <a16:creationId xmlns:a16="http://schemas.microsoft.com/office/drawing/2014/main" id="{466AFDCA-2BC4-434D-B64C-899808598C05}"/>
+                <a16:creationId xmlns:a16="http://schemas.microsoft.com/office/drawing/2014/main" id="{76B5546B-00E7-4D41-B78F-74C991996400}"/>
               </a:ext>
             </a:extLst>
           </p:cNvPr>
@@ -5936,7 +5936,7 @@
           <p:nvPr/>
         </p:nvPicPr>
         <p:blipFill>
-          <a:blip xmlns:r="http://schemas.openxmlformats.org/officeDocument/2006/relationships" xmlns:a="http://schemas.openxmlformats.org/drawingml/2006/main" r:embed="Rd51ca9d333e141ec"/>
+          <a:blip xmlns:r="http://schemas.openxmlformats.org/officeDocument/2006/relationships" xmlns:a="http://schemas.openxmlformats.org/drawingml/2006/main" r:embed="R502d920dc6614ce7"/>
           <a:stretch xmlns:a="http://schemas.openxmlformats.org/drawingml/2006/main"/>
         </p:blipFill>
         <p:spPr>
@@ -5958,7 +5958,7 @@
           <p:nvPr/>
         </p:nvPicPr>
         <p:blipFill>
-          <a:blip xmlns:r="http://schemas.openxmlformats.org/officeDocument/2006/relationships" xmlns:a="http://schemas.openxmlformats.org/drawingml/2006/main" r:embed="R1bb9942b132340e7"/>
+          <a:blip xmlns:r="http://schemas.openxmlformats.org/officeDocument/2006/relationships" xmlns:a="http://schemas.openxmlformats.org/drawingml/2006/main" r:embed="R287fed1b19724a69"/>
           <a:stretch xmlns:a="http://schemas.openxmlformats.org/drawingml/2006/main"/>
         </p:blipFill>
         <p:spPr>
@@ -5976,7 +5976,7 @@
           <p:cNvPr id="10" name="footer-label">
             <a:extLst xmlns:a="http://schemas.openxmlformats.org/drawingml/2006/main">
               <a:ext uri="{FF2B5EF4-FFF2-40B4-BE49-F238E27FC236}">
-                <a16:creationId xmlns:a16="http://schemas.microsoft.com/office/drawing/2014/main" id="{6E1EEFA6-6861-4089-886E-A9FFA6416978}"/>
+                <a16:creationId xmlns:a16="http://schemas.microsoft.com/office/drawing/2014/main" id="{94440B31-1940-4AD9-B96F-97326B698058}"/>
               </a:ext>
             </a:extLst>
           </p:cNvPr>
@@ -6041,7 +6041,7 @@
           <p:nvPr/>
         </p:nvPicPr>
         <p:blipFill>
-          <a:blip xmlns:r="http://schemas.openxmlformats.org/officeDocument/2006/relationships" xmlns:a="http://schemas.openxmlformats.org/drawingml/2006/main" r:embed="R09e4b7d90bba445c"/>
+          <a:blip xmlns:r="http://schemas.openxmlformats.org/officeDocument/2006/relationships" xmlns:a="http://schemas.openxmlformats.org/drawingml/2006/main" r:embed="Raca85ab144f24be4"/>
           <a:stretch xmlns:a="http://schemas.openxmlformats.org/drawingml/2006/main"/>
         </p:blipFill>
         <p:spPr>
@@ -6059,7 +6059,7 @@
           <p:cNvPr id="12" name="field-label">
             <a:extLst xmlns:a="http://schemas.openxmlformats.org/drawingml/2006/main">
               <a:ext uri="{FF2B5EF4-FFF2-40B4-BE49-F238E27FC236}">
-                <a16:creationId xmlns:a16="http://schemas.microsoft.com/office/drawing/2014/main" id="{9DFAE8D5-D8F2-4BEF-A362-5231E9E8E722}"/>
+                <a16:creationId xmlns:a16="http://schemas.microsoft.com/office/drawing/2014/main" id="{52C6581C-9673-41DF-B3E5-34B19C7F69E2}"/>
               </a:ext>
             </a:extLst>
           </p:cNvPr>
@@ -6118,7 +6118,7 @@
     </p:spTree>
     <p:extLst>
       <p:ext uri="{BB962C8B-B14F-4D97-AF65-F5344CB8AC3E}">
-        <p14:creationId xmlns:p14="http://schemas.microsoft.com/office/powerpoint/2010/main" val="263385835"/>
+        <p14:creationId xmlns:p14="http://schemas.microsoft.com/office/powerpoint/2010/main" val="433216434"/>
       </p:ext>
     </p:extLst>
   </p:cSld>
@@ -6149,7 +6149,7 @@
           <p:cNvPr id="9" name="slide-number">
             <a:extLst xmlns:a="http://schemas.openxmlformats.org/drawingml/2006/main">
               <a:ext uri="{FF2B5EF4-FFF2-40B4-BE49-F238E27FC236}">
-                <a16:creationId xmlns:a16="http://schemas.microsoft.com/office/drawing/2014/main" id="{2B26B79E-EEF1-41D5-B98C-B8D1C41C51A5}"/>
+                <a16:creationId xmlns:a16="http://schemas.microsoft.com/office/drawing/2014/main" id="{3F999CA6-BA9B-4C29-B9C3-9EA95C2299A0}"/>
               </a:ext>
             </a:extLst>
           </p:cNvPr>
@@ -6210,7 +6210,7 @@
           <p:cNvPr id="2" name="story-image-surface">
             <a:extLst xmlns:a="http://schemas.openxmlformats.org/drawingml/2006/main">
               <a:ext uri="{FF2B5EF4-FFF2-40B4-BE49-F238E27FC236}">
-                <a16:creationId xmlns:a16="http://schemas.microsoft.com/office/drawing/2014/main" id="{E33A4DC0-790E-49A4-966A-E5DB2F5B8B1F}"/>
+                <a16:creationId xmlns:a16="http://schemas.microsoft.com/office/drawing/2014/main" id="{37C295FC-37B4-414D-B043-F385475C305D}"/>
               </a:ext>
             </a:extLst>
           </p:cNvPr>
@@ -6244,7 +6244,7 @@
           <p:nvPr/>
         </p:nvPicPr>
         <p:blipFill>
-          <a:blip xmlns:r="http://schemas.openxmlformats.org/officeDocument/2006/relationships" xmlns:a="http://schemas.openxmlformats.org/drawingml/2006/main" r:embed="R323083ba724648f4"/>
+          <a:blip xmlns:r="http://schemas.openxmlformats.org/officeDocument/2006/relationships" xmlns:a="http://schemas.openxmlformats.org/drawingml/2006/main" r:embed="R6cdbc1db358d44d8"/>
           <a:stretch xmlns:a="http://schemas.openxmlformats.org/drawingml/2006/main"/>
         </p:blipFill>
         <p:spPr>
@@ -6262,7 +6262,7 @@
           <p:cNvPr id="4" name="section-label">
             <a:extLst xmlns:a="http://schemas.openxmlformats.org/drawingml/2006/main">
               <a:ext uri="{FF2B5EF4-FFF2-40B4-BE49-F238E27FC236}">
-                <a16:creationId xmlns:a16="http://schemas.microsoft.com/office/drawing/2014/main" id="{3E9FA02C-9DFF-4517-9C4E-A3252A1EB198}"/>
+                <a16:creationId xmlns:a16="http://schemas.microsoft.com/office/drawing/2014/main" id="{BA4FA6FD-61E6-4FFB-B8C0-65202C8141BD}"/>
               </a:ext>
             </a:extLst>
           </p:cNvPr>
@@ -6323,7 +6323,7 @@
           <p:cNvPr id="5" name="headline">
             <a:extLst xmlns:a="http://schemas.openxmlformats.org/drawingml/2006/main">
               <a:ext uri="{FF2B5EF4-FFF2-40B4-BE49-F238E27FC236}">
-                <a16:creationId xmlns:a16="http://schemas.microsoft.com/office/drawing/2014/main" id="{D0038FB7-07E3-497A-AE14-951DC17C784F}"/>
+                <a16:creationId xmlns:a16="http://schemas.microsoft.com/office/drawing/2014/main" id="{2518CD23-CC52-4972-A456-EE8C3A80F789}"/>
               </a:ext>
             </a:extLst>
           </p:cNvPr>
@@ -6411,7 +6411,7 @@
           <p:cNvPr id="6" name="story-documentary">
             <a:extLst xmlns:a="http://schemas.openxmlformats.org/drawingml/2006/main">
               <a:ext uri="{FF2B5EF4-FFF2-40B4-BE49-F238E27FC236}">
-                <a16:creationId xmlns:a16="http://schemas.microsoft.com/office/drawing/2014/main" id="{3CD81C7A-AC02-4BFA-99D1-E087C393ABA2}"/>
+                <a16:creationId xmlns:a16="http://schemas.microsoft.com/office/drawing/2014/main" id="{DA10119D-22FB-4ADB-A8C1-F0CC3463A42E}"/>
               </a:ext>
             </a:extLst>
           </p:cNvPr>
@@ -6472,7 +6472,7 @@
           <p:cNvPr id="7" name="story-now">
             <a:extLst xmlns:a="http://schemas.openxmlformats.org/drawingml/2006/main">
               <a:ext uri="{FF2B5EF4-FFF2-40B4-BE49-F238E27FC236}">
-                <a16:creationId xmlns:a16="http://schemas.microsoft.com/office/drawing/2014/main" id="{7C737751-E2FC-4396-B483-3515D32B3920}"/>
+                <a16:creationId xmlns:a16="http://schemas.microsoft.com/office/drawing/2014/main" id="{1960B4BF-794C-42F4-9AD9-2014CDAAE56E}"/>
               </a:ext>
             </a:extLst>
           </p:cNvPr>
@@ -6533,7 +6533,7 @@
           <p:cNvPr id="8" name="story-slide-number">
             <a:extLst xmlns:a="http://schemas.openxmlformats.org/drawingml/2006/main">
               <a:ext uri="{FF2B5EF4-FFF2-40B4-BE49-F238E27FC236}">
-                <a16:creationId xmlns:a16="http://schemas.microsoft.com/office/drawing/2014/main" id="{C4DFB6F9-ECB4-4831-A783-B51FCE164410}"/>
+                <a16:creationId xmlns:a16="http://schemas.microsoft.com/office/drawing/2014/main" id="{DD69DACD-7448-4426-A4BB-0DDC7F3936FE}"/>
               </a:ext>
             </a:extLst>
           </p:cNvPr>
@@ -6592,7 +6592,7 @@
     </p:spTree>
     <p:extLst>
       <p:ext uri="{BB962C8B-B14F-4D97-AF65-F5344CB8AC3E}">
-        <p14:creationId xmlns:p14="http://schemas.microsoft.com/office/powerpoint/2010/main" val="1816358066"/>
+        <p14:creationId xmlns:p14="http://schemas.microsoft.com/office/powerpoint/2010/main" val="853056310"/>
       </p:ext>
     </p:extLst>
   </p:cSld>

</xml_diff>